<commit_message>
feat: Add waterfall chart showing DPM to Customer-Facing bridge
Andy's request: Waterfall visualization bridging MFG yield to customer DPM

- Total DPM → Recovery deductions → Customer-Facing DPM
- HMB1: 266.08 → 116.13 DPM
- QMON: 192.11 → 66.23 DPM
- Combined: 61.3% recovery rate

Co-Authored-By: Claude <noreply@anthropic.com>
</commit_message>
<xml_diff>
--- a/Y6CP_cDPM_Recovery_VP_Readout_10wk.pptx
+++ b/Y6CP_cDPM_Recovery_VP_Readout_10wk.pptx
@@ -10,6 +10,7 @@
     <p:sldId id="258" r:id="rId9"/>
     <p:sldId id="259" r:id="rId10"/>
     <p:sldId id="260" r:id="rId11"/>
+    <p:sldId id="261" r:id="rId12"/>
   </p:sldIdLst>
   <p:sldSz cx="9144000" cy="6858000" type="screen4x3"/>
   <p:notesSz cx="6858000" cy="9144000"/>
@@ -7196,6 +7197,1863 @@
             </a:pPr>
             <a:r>
               <a:t>  Rationale: Row-level = potential DRAM issue</a:t>
+            </a:r>
+          </a:p>
+        </p:txBody>
+      </p:sp>
+    </p:spTree>
+  </p:cSld>
+  <p:clrMapOvr>
+    <a:masterClrMapping/>
+  </p:clrMapOvr>
+</p:sld>
+</file>
+
+<file path=ppt/slides/slide6.xml><?xml version="1.0" encoding="utf-8"?>
+<p:sld xmlns:a="http://schemas.openxmlformats.org/drawingml/2006/main" xmlns:p="http://schemas.openxmlformats.org/presentationml/2006/main" xmlns:r="http://schemas.openxmlformats.org/officeDocument/2006/relationships">
+  <p:cSld>
+    <p:spTree>
+      <p:nvGrpSpPr>
+        <p:cNvPr id="1" name=""/>
+        <p:cNvGrpSpPr/>
+        <p:nvPr/>
+      </p:nvGrpSpPr>
+      <p:grpSpPr/>
+      <p:sp>
+        <p:nvSpPr>
+          <p:cNvPr id="2" name="TextBox 1"/>
+          <p:cNvSpPr txBox="1"/>
+          <p:nvPr/>
+        </p:nvSpPr>
+        <p:spPr>
+          <a:xfrm>
+            <a:off x="274320" y="182880"/>
+            <a:ext cx="8595360" cy="457200"/>
+          </a:xfrm>
+          <a:prstGeom prst="rect">
+            <a:avLst/>
+          </a:prstGeom>
+          <a:noFill/>
+        </p:spPr>
+        <p:txBody>
+          <a:bodyPr wrap="none">
+            <a:spAutoFit/>
+          </a:bodyPr>
+          <a:lstStyle/>
+          <a:p>
+            <a:pPr>
+              <a:defRPr sz="2400" b="1">
+                <a:solidFill>
+                  <a:srgbClr val="003366"/>
+                </a:solidFill>
+              </a:defRPr>
+            </a:pPr>
+            <a:r>
+              <a:t>DPM Waterfall: Total → Customer-Facing</a:t>
+            </a:r>
+          </a:p>
+        </p:txBody>
+      </p:sp>
+      <p:sp>
+        <p:nvSpPr>
+          <p:cNvPr id="3" name="TextBox 2"/>
+          <p:cNvSpPr txBox="1"/>
+          <p:nvPr/>
+        </p:nvSpPr>
+        <p:spPr>
+          <a:xfrm>
+            <a:off x="274320" y="548640"/>
+            <a:ext cx="8595360" cy="274320"/>
+          </a:xfrm>
+          <a:prstGeom prst="rect">
+            <a:avLst/>
+          </a:prstGeom>
+          <a:noFill/>
+        </p:spPr>
+        <p:txBody>
+          <a:bodyPr wrap="none">
+            <a:spAutoFit/>
+          </a:bodyPr>
+          <a:lstStyle/>
+          <a:p>
+            <a:pPr>
+              <a:defRPr sz="1100">
+                <a:solidFill>
+                  <a:srgbClr val="646464"/>
+                </a:solidFill>
+              </a:defRPr>
+            </a:pPr>
+            <a:r>
+              <a:t>Recovery Impact Analysis | WW2608-17 | Kevin's DPM Method</a:t>
+            </a:r>
+          </a:p>
+        </p:txBody>
+      </p:sp>
+      <p:sp>
+        <p:nvSpPr>
+          <p:cNvPr id="4" name="Rectangle 3"/>
+          <p:cNvSpPr/>
+          <p:nvPr/>
+        </p:nvSpPr>
+        <p:spPr>
+          <a:xfrm>
+            <a:off x="457200" y="1305098"/>
+            <a:ext cx="426720" cy="2078181"/>
+          </a:xfrm>
+          <a:prstGeom prst="rect">
+            <a:avLst/>
+          </a:prstGeom>
+          <a:solidFill>
+            <a:srgbClr val="003366"/>
+          </a:solidFill>
+          <a:ln>
+            <a:solidFill>
+              <a:srgbClr val="323232"/>
+            </a:solidFill>
+          </a:ln>
+        </p:spPr>
+        <p:style>
+          <a:lnRef idx="1">
+            <a:schemeClr val="accent1"/>
+          </a:lnRef>
+          <a:fillRef idx="3">
+            <a:schemeClr val="accent1"/>
+          </a:fillRef>
+          <a:effectRef idx="2">
+            <a:schemeClr val="accent1"/>
+          </a:effectRef>
+          <a:fontRef idx="minor">
+            <a:schemeClr val="lt1"/>
+          </a:fontRef>
+        </p:style>
+        <p:txBody>
+          <a:bodyPr rtlCol="0" anchor="ctr"/>
+          <a:lstStyle/>
+          <a:p>
+            <a:pPr algn="ctr"/>
+          </a:p>
+        </p:txBody>
+      </p:sp>
+      <p:sp>
+        <p:nvSpPr>
+          <p:cNvPr id="5" name="TextBox 4"/>
+          <p:cNvSpPr txBox="1"/>
+          <p:nvPr/>
+        </p:nvSpPr>
+        <p:spPr>
+          <a:xfrm>
+            <a:off x="457200" y="2207029"/>
+            <a:ext cx="426720" cy="274320"/>
+          </a:xfrm>
+          <a:prstGeom prst="rect">
+            <a:avLst/>
+          </a:prstGeom>
+          <a:noFill/>
+        </p:spPr>
+        <p:txBody>
+          <a:bodyPr wrap="none">
+            <a:spAutoFit/>
+          </a:bodyPr>
+          <a:lstStyle/>
+          <a:p>
+            <a:pPr algn="ctr">
+              <a:defRPr sz="900" b="1">
+                <a:solidFill>
+                  <a:srgbClr val="FFFFFF"/>
+                </a:solidFill>
+              </a:defRPr>
+            </a:pPr>
+            <a:r>
+              <a:t>266.1</a:t>
+            </a:r>
+          </a:p>
+        </p:txBody>
+      </p:sp>
+      <p:sp>
+        <p:nvSpPr>
+          <p:cNvPr id="6" name="TextBox 5"/>
+          <p:cNvSpPr txBox="1"/>
+          <p:nvPr/>
+        </p:nvSpPr>
+        <p:spPr>
+          <a:xfrm>
+            <a:off x="365760" y="3429000"/>
+            <a:ext cx="609600" cy="365760"/>
+          </a:xfrm>
+          <a:prstGeom prst="rect">
+            <a:avLst/>
+          </a:prstGeom>
+          <a:noFill/>
+        </p:spPr>
+        <p:txBody>
+          <a:bodyPr wrap="none">
+            <a:spAutoFit/>
+          </a:bodyPr>
+          <a:lstStyle/>
+          <a:p>
+            <a:pPr algn="ctr">
+              <a:defRPr sz="700"/>
+            </a:pPr>
+            <a:r>
+              <a:t>Total DPM</a:t>
+            </a:r>
+          </a:p>
+        </p:txBody>
+      </p:sp>
+      <p:sp>
+        <p:nvSpPr>
+          <p:cNvPr id="7" name="Rectangle 6"/>
+          <p:cNvSpPr/>
+          <p:nvPr/>
+        </p:nvSpPr>
+        <p:spPr>
+          <a:xfrm>
+            <a:off x="1097280" y="1305098"/>
+            <a:ext cx="426720" cy="754938"/>
+          </a:xfrm>
+          <a:prstGeom prst="rect">
+            <a:avLst/>
+          </a:prstGeom>
+          <a:solidFill>
+            <a:srgbClr val="2E8B57"/>
+          </a:solidFill>
+          <a:ln>
+            <a:solidFill>
+              <a:srgbClr val="323232"/>
+            </a:solidFill>
+          </a:ln>
+        </p:spPr>
+        <p:style>
+          <a:lnRef idx="1">
+            <a:schemeClr val="accent1"/>
+          </a:lnRef>
+          <a:fillRef idx="3">
+            <a:schemeClr val="accent1"/>
+          </a:fillRef>
+          <a:effectRef idx="2">
+            <a:schemeClr val="accent1"/>
+          </a:effectRef>
+          <a:fontRef idx="minor">
+            <a:schemeClr val="lt1"/>
+          </a:fontRef>
+        </p:style>
+        <p:txBody>
+          <a:bodyPr rtlCol="0" anchor="ctr"/>
+          <a:lstStyle/>
+          <a:p>
+            <a:pPr algn="ctr"/>
+          </a:p>
+        </p:txBody>
+      </p:sp>
+      <p:sp>
+        <p:nvSpPr>
+          <p:cNvPr id="8" name="TextBox 7"/>
+          <p:cNvSpPr txBox="1"/>
+          <p:nvPr/>
+        </p:nvSpPr>
+        <p:spPr>
+          <a:xfrm>
+            <a:off x="1097280" y="1545407"/>
+            <a:ext cx="426720" cy="274320"/>
+          </a:xfrm>
+          <a:prstGeom prst="rect">
+            <a:avLst/>
+          </a:prstGeom>
+          <a:noFill/>
+        </p:spPr>
+        <p:txBody>
+          <a:bodyPr wrap="none">
+            <a:spAutoFit/>
+          </a:bodyPr>
+          <a:lstStyle/>
+          <a:p>
+            <a:pPr algn="ctr">
+              <a:defRPr sz="900" b="1">
+                <a:solidFill>
+                  <a:srgbClr val="FFFFFF"/>
+                </a:solidFill>
+              </a:defRPr>
+            </a:pPr>
+            <a:r>
+              <a:t>-96.7</a:t>
+            </a:r>
+          </a:p>
+        </p:txBody>
+      </p:sp>
+      <p:sp>
+        <p:nvSpPr>
+          <p:cNvPr id="9" name="TextBox 8"/>
+          <p:cNvSpPr txBox="1"/>
+          <p:nvPr/>
+        </p:nvSpPr>
+        <p:spPr>
+          <a:xfrm>
+            <a:off x="1005839" y="3429000"/>
+            <a:ext cx="609600" cy="365760"/>
+          </a:xfrm>
+          <a:prstGeom prst="rect">
+            <a:avLst/>
+          </a:prstGeom>
+          <a:noFill/>
+        </p:spPr>
+        <p:txBody>
+          <a:bodyPr wrap="none">
+            <a:spAutoFit/>
+          </a:bodyPr>
+          <a:lstStyle/>
+          <a:p>
+            <a:pPr algn="ctr">
+              <a:defRPr sz="700"/>
+            </a:pPr>
+            <a:r>
+              <a:t>BIOS 100%</a:t>
+            </a:r>
+          </a:p>
+        </p:txBody>
+      </p:sp>
+      <p:sp>
+        <p:nvSpPr>
+          <p:cNvPr id="10" name="Rectangle 9"/>
+          <p:cNvSpPr/>
+          <p:nvPr/>
+        </p:nvSpPr>
+        <p:spPr>
+          <a:xfrm>
+            <a:off x="1737360" y="2060037"/>
+            <a:ext cx="426720" cy="281715"/>
+          </a:xfrm>
+          <a:prstGeom prst="rect">
+            <a:avLst/>
+          </a:prstGeom>
+          <a:solidFill>
+            <a:srgbClr val="2E8B57"/>
+          </a:solidFill>
+          <a:ln>
+            <a:solidFill>
+              <a:srgbClr val="323232"/>
+            </a:solidFill>
+          </a:ln>
+        </p:spPr>
+        <p:style>
+          <a:lnRef idx="1">
+            <a:schemeClr val="accent1"/>
+          </a:lnRef>
+          <a:fillRef idx="3">
+            <a:schemeClr val="accent1"/>
+          </a:fillRef>
+          <a:effectRef idx="2">
+            <a:schemeClr val="accent1"/>
+          </a:effectRef>
+          <a:fontRef idx="minor">
+            <a:schemeClr val="lt1"/>
+          </a:fontRef>
+        </p:style>
+        <p:txBody>
+          <a:bodyPr rtlCol="0" anchor="ctr"/>
+          <a:lstStyle/>
+          <a:p>
+            <a:pPr algn="ctr"/>
+          </a:p>
+        </p:txBody>
+      </p:sp>
+      <p:sp>
+        <p:nvSpPr>
+          <p:cNvPr id="11" name="TextBox 10"/>
+          <p:cNvSpPr txBox="1"/>
+          <p:nvPr/>
+        </p:nvSpPr>
+        <p:spPr>
+          <a:xfrm>
+            <a:off x="1737360" y="2063734"/>
+            <a:ext cx="426720" cy="274320"/>
+          </a:xfrm>
+          <a:prstGeom prst="rect">
+            <a:avLst/>
+          </a:prstGeom>
+          <a:noFill/>
+        </p:spPr>
+        <p:txBody>
+          <a:bodyPr wrap="none">
+            <a:spAutoFit/>
+          </a:bodyPr>
+          <a:lstStyle/>
+          <a:p>
+            <a:pPr algn="ctr">
+              <a:defRPr sz="900" b="1">
+                <a:solidFill>
+                  <a:srgbClr val="FFFFFF"/>
+                </a:solidFill>
+              </a:defRPr>
+            </a:pPr>
+            <a:r>
+              <a:t>-36.1</a:t>
+            </a:r>
+          </a:p>
+        </p:txBody>
+      </p:sp>
+      <p:sp>
+        <p:nvSpPr>
+          <p:cNvPr id="12" name="TextBox 11"/>
+          <p:cNvSpPr txBox="1"/>
+          <p:nvPr/>
+        </p:nvSpPr>
+        <p:spPr>
+          <a:xfrm>
+            <a:off x="1645919" y="3429000"/>
+            <a:ext cx="609600" cy="365760"/>
+          </a:xfrm>
+          <a:prstGeom prst="rect">
+            <a:avLst/>
+          </a:prstGeom>
+          <a:noFill/>
+        </p:spPr>
+        <p:txBody>
+          <a:bodyPr wrap="none">
+            <a:spAutoFit/>
+          </a:bodyPr>
+          <a:lstStyle/>
+          <a:p>
+            <a:pPr algn="ctr">
+              <a:defRPr sz="700"/>
+            </a:pPr>
+            <a:r>
+              <a:t>BIOS 50%</a:t>
+            </a:r>
+          </a:p>
+        </p:txBody>
+      </p:sp>
+      <p:sp>
+        <p:nvSpPr>
+          <p:cNvPr id="13" name="Rectangle 12"/>
+          <p:cNvSpPr/>
+          <p:nvPr/>
+        </p:nvSpPr>
+        <p:spPr>
+          <a:xfrm>
+            <a:off x="2377439" y="2341752"/>
+            <a:ext cx="426720" cy="134492"/>
+          </a:xfrm>
+          <a:prstGeom prst="rect">
+            <a:avLst/>
+          </a:prstGeom>
+          <a:solidFill>
+            <a:srgbClr val="2E8B57"/>
+          </a:solidFill>
+          <a:ln>
+            <a:solidFill>
+              <a:srgbClr val="323232"/>
+            </a:solidFill>
+          </a:ln>
+        </p:spPr>
+        <p:style>
+          <a:lnRef idx="1">
+            <a:schemeClr val="accent1"/>
+          </a:lnRef>
+          <a:fillRef idx="3">
+            <a:schemeClr val="accent1"/>
+          </a:fillRef>
+          <a:effectRef idx="2">
+            <a:schemeClr val="accent1"/>
+          </a:effectRef>
+          <a:fontRef idx="minor">
+            <a:schemeClr val="lt1"/>
+          </a:fontRef>
+        </p:style>
+        <p:txBody>
+          <a:bodyPr rtlCol="0" anchor="ctr"/>
+          <a:lstStyle/>
+          <a:p>
+            <a:pPr algn="ctr"/>
+          </a:p>
+        </p:txBody>
+      </p:sp>
+      <p:sp>
+        <p:nvSpPr>
+          <p:cNvPr id="14" name="TextBox 13"/>
+          <p:cNvSpPr txBox="1"/>
+          <p:nvPr/>
+        </p:nvSpPr>
+        <p:spPr>
+          <a:xfrm>
+            <a:off x="2285999" y="3429000"/>
+            <a:ext cx="609600" cy="365760"/>
+          </a:xfrm>
+          <a:prstGeom prst="rect">
+            <a:avLst/>
+          </a:prstGeom>
+          <a:noFill/>
+        </p:spPr>
+        <p:txBody>
+          <a:bodyPr wrap="none">
+            <a:spAutoFit/>
+          </a:bodyPr>
+          <a:lstStyle/>
+          <a:p>
+            <a:pPr algn="ctr">
+              <a:defRPr sz="700"/>
+            </a:pPr>
+            <a:r>
+              <a:t>HW+SOP</a:t>
+            </a:r>
+          </a:p>
+        </p:txBody>
+      </p:sp>
+      <p:sp>
+        <p:nvSpPr>
+          <p:cNvPr id="15" name="Rectangle 14"/>
+          <p:cNvSpPr/>
+          <p:nvPr/>
+        </p:nvSpPr>
+        <p:spPr>
+          <a:xfrm>
+            <a:off x="3017520" y="2476245"/>
+            <a:ext cx="426720" cy="27320"/>
+          </a:xfrm>
+          <a:prstGeom prst="rect">
+            <a:avLst/>
+          </a:prstGeom>
+          <a:solidFill>
+            <a:srgbClr val="2E8B57"/>
+          </a:solidFill>
+          <a:ln>
+            <a:solidFill>
+              <a:srgbClr val="323232"/>
+            </a:solidFill>
+          </a:ln>
+        </p:spPr>
+        <p:style>
+          <a:lnRef idx="1">
+            <a:schemeClr val="accent1"/>
+          </a:lnRef>
+          <a:fillRef idx="3">
+            <a:schemeClr val="accent1"/>
+          </a:fillRef>
+          <a:effectRef idx="2">
+            <a:schemeClr val="accent1"/>
+          </a:effectRef>
+          <a:fontRef idx="minor">
+            <a:schemeClr val="lt1"/>
+          </a:fontRef>
+        </p:style>
+        <p:txBody>
+          <a:bodyPr rtlCol="0" anchor="ctr"/>
+          <a:lstStyle/>
+          <a:p>
+            <a:pPr algn="ctr"/>
+          </a:p>
+        </p:txBody>
+      </p:sp>
+      <p:sp>
+        <p:nvSpPr>
+          <p:cNvPr id="16" name="TextBox 15"/>
+          <p:cNvSpPr txBox="1"/>
+          <p:nvPr/>
+        </p:nvSpPr>
+        <p:spPr>
+          <a:xfrm>
+            <a:off x="2926079" y="3429000"/>
+            <a:ext cx="609600" cy="365760"/>
+          </a:xfrm>
+          <a:prstGeom prst="rect">
+            <a:avLst/>
+          </a:prstGeom>
+          <a:noFill/>
+        </p:spPr>
+        <p:txBody>
+          <a:bodyPr wrap="none">
+            <a:spAutoFit/>
+          </a:bodyPr>
+          <a:lstStyle/>
+          <a:p>
+            <a:pPr algn="ctr">
+              <a:defRPr sz="700"/>
+            </a:pPr>
+            <a:r>
+              <a:t>RPx</a:t>
+            </a:r>
+          </a:p>
+        </p:txBody>
+      </p:sp>
+      <p:sp>
+        <p:nvSpPr>
+          <p:cNvPr id="17" name="Rectangle 16"/>
+          <p:cNvSpPr/>
+          <p:nvPr/>
+        </p:nvSpPr>
+        <p:spPr>
+          <a:xfrm>
+            <a:off x="3657600" y="2503565"/>
+            <a:ext cx="426720" cy="879714"/>
+          </a:xfrm>
+          <a:prstGeom prst="rect">
+            <a:avLst/>
+          </a:prstGeom>
+          <a:solidFill>
+            <a:srgbClr val="DC143C"/>
+          </a:solidFill>
+          <a:ln>
+            <a:solidFill>
+              <a:srgbClr val="323232"/>
+            </a:solidFill>
+          </a:ln>
+        </p:spPr>
+        <p:style>
+          <a:lnRef idx="1">
+            <a:schemeClr val="accent1"/>
+          </a:lnRef>
+          <a:fillRef idx="3">
+            <a:schemeClr val="accent1"/>
+          </a:fillRef>
+          <a:effectRef idx="2">
+            <a:schemeClr val="accent1"/>
+          </a:effectRef>
+          <a:fontRef idx="minor">
+            <a:schemeClr val="lt1"/>
+          </a:fontRef>
+        </p:style>
+        <p:txBody>
+          <a:bodyPr rtlCol="0" anchor="ctr"/>
+          <a:lstStyle/>
+          <a:p>
+            <a:pPr algn="ctr"/>
+          </a:p>
+        </p:txBody>
+      </p:sp>
+      <p:sp>
+        <p:nvSpPr>
+          <p:cNvPr id="18" name="TextBox 17"/>
+          <p:cNvSpPr txBox="1"/>
+          <p:nvPr/>
+        </p:nvSpPr>
+        <p:spPr>
+          <a:xfrm>
+            <a:off x="3657600" y="2806262"/>
+            <a:ext cx="426720" cy="274320"/>
+          </a:xfrm>
+          <a:prstGeom prst="rect">
+            <a:avLst/>
+          </a:prstGeom>
+          <a:noFill/>
+        </p:spPr>
+        <p:txBody>
+          <a:bodyPr wrap="none">
+            <a:spAutoFit/>
+          </a:bodyPr>
+          <a:lstStyle/>
+          <a:p>
+            <a:pPr algn="ctr">
+              <a:defRPr sz="900" b="1">
+                <a:solidFill>
+                  <a:srgbClr val="FFFFFF"/>
+                </a:solidFill>
+              </a:defRPr>
+            </a:pPr>
+            <a:r>
+              <a:t>112.6</a:t>
+            </a:r>
+          </a:p>
+        </p:txBody>
+      </p:sp>
+      <p:sp>
+        <p:nvSpPr>
+          <p:cNvPr id="19" name="TextBox 18"/>
+          <p:cNvSpPr txBox="1"/>
+          <p:nvPr/>
+        </p:nvSpPr>
+        <p:spPr>
+          <a:xfrm>
+            <a:off x="3566160" y="3429000"/>
+            <a:ext cx="609600" cy="365760"/>
+          </a:xfrm>
+          <a:prstGeom prst="rect">
+            <a:avLst/>
+          </a:prstGeom>
+          <a:noFill/>
+        </p:spPr>
+        <p:txBody>
+          <a:bodyPr wrap="none">
+            <a:spAutoFit/>
+          </a:bodyPr>
+          <a:lstStyle/>
+          <a:p>
+            <a:pPr algn="ctr">
+              <a:defRPr sz="700"/>
+            </a:pPr>
+            <a:r>
+              <a:t>Customer</a:t>
+            </a:r>
+            <a:br/>
+            <a:r>
+              <a:t>Facing</a:t>
+            </a:r>
+          </a:p>
+        </p:txBody>
+      </p:sp>
+      <p:sp>
+        <p:nvSpPr>
+          <p:cNvPr id="20" name="Rectangle 19"/>
+          <p:cNvSpPr/>
+          <p:nvPr/>
+        </p:nvSpPr>
+        <p:spPr>
+          <a:xfrm>
+            <a:off x="883920" y="1305098"/>
+            <a:ext cx="213359" cy="18288"/>
+          </a:xfrm>
+          <a:prstGeom prst="rect">
+            <a:avLst/>
+          </a:prstGeom>
+          <a:solidFill>
+            <a:srgbClr val="969696"/>
+          </a:solidFill>
+          <a:ln>
+            <a:noFill/>
+          </a:ln>
+        </p:spPr>
+        <p:style>
+          <a:lnRef idx="1">
+            <a:schemeClr val="accent1"/>
+          </a:lnRef>
+          <a:fillRef idx="3">
+            <a:schemeClr val="accent1"/>
+          </a:fillRef>
+          <a:effectRef idx="2">
+            <a:schemeClr val="accent1"/>
+          </a:effectRef>
+          <a:fontRef idx="minor">
+            <a:schemeClr val="lt1"/>
+          </a:fontRef>
+        </p:style>
+        <p:txBody>
+          <a:bodyPr rtlCol="0" anchor="ctr"/>
+          <a:lstStyle/>
+          <a:p>
+            <a:pPr algn="ctr"/>
+          </a:p>
+        </p:txBody>
+      </p:sp>
+      <p:sp>
+        <p:nvSpPr>
+          <p:cNvPr id="21" name="Rectangle 20"/>
+          <p:cNvSpPr/>
+          <p:nvPr/>
+        </p:nvSpPr>
+        <p:spPr>
+          <a:xfrm>
+            <a:off x="1523999" y="2060037"/>
+            <a:ext cx="213360" cy="18288"/>
+          </a:xfrm>
+          <a:prstGeom prst="rect">
+            <a:avLst/>
+          </a:prstGeom>
+          <a:solidFill>
+            <a:srgbClr val="969696"/>
+          </a:solidFill>
+          <a:ln>
+            <a:noFill/>
+          </a:ln>
+        </p:spPr>
+        <p:style>
+          <a:lnRef idx="1">
+            <a:schemeClr val="accent1"/>
+          </a:lnRef>
+          <a:fillRef idx="3">
+            <a:schemeClr val="accent1"/>
+          </a:fillRef>
+          <a:effectRef idx="2">
+            <a:schemeClr val="accent1"/>
+          </a:effectRef>
+          <a:fontRef idx="minor">
+            <a:schemeClr val="lt1"/>
+          </a:fontRef>
+        </p:style>
+        <p:txBody>
+          <a:bodyPr rtlCol="0" anchor="ctr"/>
+          <a:lstStyle/>
+          <a:p>
+            <a:pPr algn="ctr"/>
+          </a:p>
+        </p:txBody>
+      </p:sp>
+      <p:sp>
+        <p:nvSpPr>
+          <p:cNvPr id="22" name="Rectangle 21"/>
+          <p:cNvSpPr/>
+          <p:nvPr/>
+        </p:nvSpPr>
+        <p:spPr>
+          <a:xfrm>
+            <a:off x="2164080" y="2341752"/>
+            <a:ext cx="213359" cy="18288"/>
+          </a:xfrm>
+          <a:prstGeom prst="rect">
+            <a:avLst/>
+          </a:prstGeom>
+          <a:solidFill>
+            <a:srgbClr val="969696"/>
+          </a:solidFill>
+          <a:ln>
+            <a:noFill/>
+          </a:ln>
+        </p:spPr>
+        <p:style>
+          <a:lnRef idx="1">
+            <a:schemeClr val="accent1"/>
+          </a:lnRef>
+          <a:fillRef idx="3">
+            <a:schemeClr val="accent1"/>
+          </a:fillRef>
+          <a:effectRef idx="2">
+            <a:schemeClr val="accent1"/>
+          </a:effectRef>
+          <a:fontRef idx="minor">
+            <a:schemeClr val="lt1"/>
+          </a:fontRef>
+        </p:style>
+        <p:txBody>
+          <a:bodyPr rtlCol="0" anchor="ctr"/>
+          <a:lstStyle/>
+          <a:p>
+            <a:pPr algn="ctr"/>
+          </a:p>
+        </p:txBody>
+      </p:sp>
+      <p:sp>
+        <p:nvSpPr>
+          <p:cNvPr id="23" name="Rectangle 22"/>
+          <p:cNvSpPr/>
+          <p:nvPr/>
+        </p:nvSpPr>
+        <p:spPr>
+          <a:xfrm>
+            <a:off x="2804160" y="2476245"/>
+            <a:ext cx="213360" cy="18288"/>
+          </a:xfrm>
+          <a:prstGeom prst="rect">
+            <a:avLst/>
+          </a:prstGeom>
+          <a:solidFill>
+            <a:srgbClr val="969696"/>
+          </a:solidFill>
+          <a:ln>
+            <a:noFill/>
+          </a:ln>
+        </p:spPr>
+        <p:style>
+          <a:lnRef idx="1">
+            <a:schemeClr val="accent1"/>
+          </a:lnRef>
+          <a:fillRef idx="3">
+            <a:schemeClr val="accent1"/>
+          </a:fillRef>
+          <a:effectRef idx="2">
+            <a:schemeClr val="accent1"/>
+          </a:effectRef>
+          <a:fontRef idx="minor">
+            <a:schemeClr val="lt1"/>
+          </a:fontRef>
+        </p:style>
+        <p:txBody>
+          <a:bodyPr rtlCol="0" anchor="ctr"/>
+          <a:lstStyle/>
+          <a:p>
+            <a:pPr algn="ctr"/>
+          </a:p>
+        </p:txBody>
+      </p:sp>
+      <p:sp>
+        <p:nvSpPr>
+          <p:cNvPr id="24" name="Rectangle 23"/>
+          <p:cNvSpPr/>
+          <p:nvPr/>
+        </p:nvSpPr>
+        <p:spPr>
+          <a:xfrm>
+            <a:off x="3444240" y="2503565"/>
+            <a:ext cx="213360" cy="18288"/>
+          </a:xfrm>
+          <a:prstGeom prst="rect">
+            <a:avLst/>
+          </a:prstGeom>
+          <a:solidFill>
+            <a:srgbClr val="969696"/>
+          </a:solidFill>
+          <a:ln>
+            <a:noFill/>
+          </a:ln>
+        </p:spPr>
+        <p:style>
+          <a:lnRef idx="1">
+            <a:schemeClr val="accent1"/>
+          </a:lnRef>
+          <a:fillRef idx="3">
+            <a:schemeClr val="accent1"/>
+          </a:fillRef>
+          <a:effectRef idx="2">
+            <a:schemeClr val="accent1"/>
+          </a:effectRef>
+          <a:fontRef idx="minor">
+            <a:schemeClr val="lt1"/>
+          </a:fontRef>
+        </p:style>
+        <p:txBody>
+          <a:bodyPr rtlCol="0" anchor="ctr"/>
+          <a:lstStyle/>
+          <a:p>
+            <a:pPr algn="ctr"/>
+          </a:p>
+        </p:txBody>
+      </p:sp>
+      <p:sp>
+        <p:nvSpPr>
+          <p:cNvPr id="25" name="TextBox 24"/>
+          <p:cNvSpPr txBox="1"/>
+          <p:nvPr/>
+        </p:nvSpPr>
+        <p:spPr>
+          <a:xfrm>
+            <a:off x="457200" y="731519"/>
+            <a:ext cx="3840480" cy="274320"/>
+          </a:xfrm>
+          <a:prstGeom prst="rect">
+            <a:avLst/>
+          </a:prstGeom>
+          <a:noFill/>
+        </p:spPr>
+        <p:txBody>
+          <a:bodyPr wrap="none">
+            <a:spAutoFit/>
+          </a:bodyPr>
+          <a:lstStyle/>
+          <a:p>
+            <a:pPr algn="ctr">
+              <a:defRPr sz="1200" b="1"/>
+            </a:pPr>
+            <a:r>
+              <a:t>HMB1</a:t>
+            </a:r>
+          </a:p>
+        </p:txBody>
+      </p:sp>
+      <p:sp>
+        <p:nvSpPr>
+          <p:cNvPr id="26" name="Rectangle 25"/>
+          <p:cNvSpPr/>
+          <p:nvPr/>
+        </p:nvSpPr>
+        <p:spPr>
+          <a:xfrm>
+            <a:off x="4846320" y="1305098"/>
+            <a:ext cx="426720" cy="2078181"/>
+          </a:xfrm>
+          <a:prstGeom prst="rect">
+            <a:avLst/>
+          </a:prstGeom>
+          <a:solidFill>
+            <a:srgbClr val="003366"/>
+          </a:solidFill>
+          <a:ln>
+            <a:solidFill>
+              <a:srgbClr val="323232"/>
+            </a:solidFill>
+          </a:ln>
+        </p:spPr>
+        <p:style>
+          <a:lnRef idx="1">
+            <a:schemeClr val="accent1"/>
+          </a:lnRef>
+          <a:fillRef idx="3">
+            <a:schemeClr val="accent1"/>
+          </a:fillRef>
+          <a:effectRef idx="2">
+            <a:schemeClr val="accent1"/>
+          </a:effectRef>
+          <a:fontRef idx="minor">
+            <a:schemeClr val="lt1"/>
+          </a:fontRef>
+        </p:style>
+        <p:txBody>
+          <a:bodyPr rtlCol="0" anchor="ctr"/>
+          <a:lstStyle/>
+          <a:p>
+            <a:pPr algn="ctr"/>
+          </a:p>
+        </p:txBody>
+      </p:sp>
+      <p:sp>
+        <p:nvSpPr>
+          <p:cNvPr id="27" name="TextBox 26"/>
+          <p:cNvSpPr txBox="1"/>
+          <p:nvPr/>
+        </p:nvSpPr>
+        <p:spPr>
+          <a:xfrm>
+            <a:off x="4846320" y="2207029"/>
+            <a:ext cx="426720" cy="274320"/>
+          </a:xfrm>
+          <a:prstGeom prst="rect">
+            <a:avLst/>
+          </a:prstGeom>
+          <a:noFill/>
+        </p:spPr>
+        <p:txBody>
+          <a:bodyPr wrap="none">
+            <a:spAutoFit/>
+          </a:bodyPr>
+          <a:lstStyle/>
+          <a:p>
+            <a:pPr algn="ctr">
+              <a:defRPr sz="900" b="1">
+                <a:solidFill>
+                  <a:srgbClr val="FFFFFF"/>
+                </a:solidFill>
+              </a:defRPr>
+            </a:pPr>
+            <a:r>
+              <a:t>192.1</a:t>
+            </a:r>
+          </a:p>
+        </p:txBody>
+      </p:sp>
+      <p:sp>
+        <p:nvSpPr>
+          <p:cNvPr id="28" name="TextBox 27"/>
+          <p:cNvSpPr txBox="1"/>
+          <p:nvPr/>
+        </p:nvSpPr>
+        <p:spPr>
+          <a:xfrm>
+            <a:off x="4754880" y="3429000"/>
+            <a:ext cx="609600" cy="365760"/>
+          </a:xfrm>
+          <a:prstGeom prst="rect">
+            <a:avLst/>
+          </a:prstGeom>
+          <a:noFill/>
+        </p:spPr>
+        <p:txBody>
+          <a:bodyPr wrap="none">
+            <a:spAutoFit/>
+          </a:bodyPr>
+          <a:lstStyle/>
+          <a:p>
+            <a:pPr algn="ctr">
+              <a:defRPr sz="700"/>
+            </a:pPr>
+            <a:r>
+              <a:t>Total DPM</a:t>
+            </a:r>
+          </a:p>
+        </p:txBody>
+      </p:sp>
+      <p:sp>
+        <p:nvSpPr>
+          <p:cNvPr id="29" name="Rectangle 28"/>
+          <p:cNvSpPr/>
+          <p:nvPr/>
+        </p:nvSpPr>
+        <p:spPr>
+          <a:xfrm>
+            <a:off x="5486400" y="1305098"/>
+            <a:ext cx="426720" cy="1116491"/>
+          </a:xfrm>
+          <a:prstGeom prst="rect">
+            <a:avLst/>
+          </a:prstGeom>
+          <a:solidFill>
+            <a:srgbClr val="2E8B57"/>
+          </a:solidFill>
+          <a:ln>
+            <a:solidFill>
+              <a:srgbClr val="323232"/>
+            </a:solidFill>
+          </a:ln>
+        </p:spPr>
+        <p:style>
+          <a:lnRef idx="1">
+            <a:schemeClr val="accent1"/>
+          </a:lnRef>
+          <a:fillRef idx="3">
+            <a:schemeClr val="accent1"/>
+          </a:fillRef>
+          <a:effectRef idx="2">
+            <a:schemeClr val="accent1"/>
+          </a:effectRef>
+          <a:fontRef idx="minor">
+            <a:schemeClr val="lt1"/>
+          </a:fontRef>
+        </p:style>
+        <p:txBody>
+          <a:bodyPr rtlCol="0" anchor="ctr"/>
+          <a:lstStyle/>
+          <a:p>
+            <a:pPr algn="ctr"/>
+          </a:p>
+        </p:txBody>
+      </p:sp>
+      <p:sp>
+        <p:nvSpPr>
+          <p:cNvPr id="30" name="TextBox 29"/>
+          <p:cNvSpPr txBox="1"/>
+          <p:nvPr/>
+        </p:nvSpPr>
+        <p:spPr>
+          <a:xfrm>
+            <a:off x="5486400" y="1726184"/>
+            <a:ext cx="426720" cy="274320"/>
+          </a:xfrm>
+          <a:prstGeom prst="rect">
+            <a:avLst/>
+          </a:prstGeom>
+          <a:noFill/>
+        </p:spPr>
+        <p:txBody>
+          <a:bodyPr wrap="none">
+            <a:spAutoFit/>
+          </a:bodyPr>
+          <a:lstStyle/>
+          <a:p>
+            <a:pPr algn="ctr">
+              <a:defRPr sz="900" b="1">
+                <a:solidFill>
+                  <a:srgbClr val="FFFFFF"/>
+                </a:solidFill>
+              </a:defRPr>
+            </a:pPr>
+            <a:r>
+              <a:t>-103.2</a:t>
+            </a:r>
+          </a:p>
+        </p:txBody>
+      </p:sp>
+      <p:sp>
+        <p:nvSpPr>
+          <p:cNvPr id="31" name="TextBox 30"/>
+          <p:cNvSpPr txBox="1"/>
+          <p:nvPr/>
+        </p:nvSpPr>
+        <p:spPr>
+          <a:xfrm>
+            <a:off x="5394960" y="3429000"/>
+            <a:ext cx="609600" cy="365760"/>
+          </a:xfrm>
+          <a:prstGeom prst="rect">
+            <a:avLst/>
+          </a:prstGeom>
+          <a:noFill/>
+        </p:spPr>
+        <p:txBody>
+          <a:bodyPr wrap="none">
+            <a:spAutoFit/>
+          </a:bodyPr>
+          <a:lstStyle/>
+          <a:p>
+            <a:pPr algn="ctr">
+              <a:defRPr sz="700"/>
+            </a:pPr>
+            <a:r>
+              <a:t>BIOS 100%</a:t>
+            </a:r>
+          </a:p>
+        </p:txBody>
+      </p:sp>
+      <p:sp>
+        <p:nvSpPr>
+          <p:cNvPr id="32" name="Rectangle 31"/>
+          <p:cNvSpPr/>
+          <p:nvPr/>
+        </p:nvSpPr>
+        <p:spPr>
+          <a:xfrm>
+            <a:off x="6126479" y="2421589"/>
+            <a:ext cx="426720" cy="238259"/>
+          </a:xfrm>
+          <a:prstGeom prst="rect">
+            <a:avLst/>
+          </a:prstGeom>
+          <a:solidFill>
+            <a:srgbClr val="2E8B57"/>
+          </a:solidFill>
+          <a:ln>
+            <a:solidFill>
+              <a:srgbClr val="323232"/>
+            </a:solidFill>
+          </a:ln>
+        </p:spPr>
+        <p:style>
+          <a:lnRef idx="1">
+            <a:schemeClr val="accent1"/>
+          </a:lnRef>
+          <a:fillRef idx="3">
+            <a:schemeClr val="accent1"/>
+          </a:fillRef>
+          <a:effectRef idx="2">
+            <a:schemeClr val="accent1"/>
+          </a:effectRef>
+          <a:fontRef idx="minor">
+            <a:schemeClr val="lt1"/>
+          </a:fontRef>
+        </p:style>
+        <p:txBody>
+          <a:bodyPr rtlCol="0" anchor="ctr"/>
+          <a:lstStyle/>
+          <a:p>
+            <a:pPr algn="ctr"/>
+          </a:p>
+        </p:txBody>
+      </p:sp>
+      <p:sp>
+        <p:nvSpPr>
+          <p:cNvPr id="33" name="TextBox 32"/>
+          <p:cNvSpPr txBox="1"/>
+          <p:nvPr/>
+        </p:nvSpPr>
+        <p:spPr>
+          <a:xfrm>
+            <a:off x="6035040" y="3429000"/>
+            <a:ext cx="609600" cy="365760"/>
+          </a:xfrm>
+          <a:prstGeom prst="rect">
+            <a:avLst/>
+          </a:prstGeom>
+          <a:noFill/>
+        </p:spPr>
+        <p:txBody>
+          <a:bodyPr wrap="none">
+            <a:spAutoFit/>
+          </a:bodyPr>
+          <a:lstStyle/>
+          <a:p>
+            <a:pPr algn="ctr">
+              <a:defRPr sz="700"/>
+            </a:pPr>
+            <a:r>
+              <a:t>BIOS 50%</a:t>
+            </a:r>
+          </a:p>
+        </p:txBody>
+      </p:sp>
+      <p:sp>
+        <p:nvSpPr>
+          <p:cNvPr id="34" name="Rectangle 33"/>
+          <p:cNvSpPr/>
+          <p:nvPr/>
+        </p:nvSpPr>
+        <p:spPr>
+          <a:xfrm>
+            <a:off x="6766559" y="2659849"/>
+            <a:ext cx="426720" cy="6923"/>
+          </a:xfrm>
+          <a:prstGeom prst="rect">
+            <a:avLst/>
+          </a:prstGeom>
+          <a:solidFill>
+            <a:srgbClr val="2E8B57"/>
+          </a:solidFill>
+          <a:ln>
+            <a:solidFill>
+              <a:srgbClr val="323232"/>
+            </a:solidFill>
+          </a:ln>
+        </p:spPr>
+        <p:style>
+          <a:lnRef idx="1">
+            <a:schemeClr val="accent1"/>
+          </a:lnRef>
+          <a:fillRef idx="3">
+            <a:schemeClr val="accent1"/>
+          </a:fillRef>
+          <a:effectRef idx="2">
+            <a:schemeClr val="accent1"/>
+          </a:effectRef>
+          <a:fontRef idx="minor">
+            <a:schemeClr val="lt1"/>
+          </a:fontRef>
+        </p:style>
+        <p:txBody>
+          <a:bodyPr rtlCol="0" anchor="ctr"/>
+          <a:lstStyle/>
+          <a:p>
+            <a:pPr algn="ctr"/>
+          </a:p>
+        </p:txBody>
+      </p:sp>
+      <p:sp>
+        <p:nvSpPr>
+          <p:cNvPr id="35" name="TextBox 34"/>
+          <p:cNvSpPr txBox="1"/>
+          <p:nvPr/>
+        </p:nvSpPr>
+        <p:spPr>
+          <a:xfrm>
+            <a:off x="6675120" y="3429000"/>
+            <a:ext cx="609600" cy="365760"/>
+          </a:xfrm>
+          <a:prstGeom prst="rect">
+            <a:avLst/>
+          </a:prstGeom>
+          <a:noFill/>
+        </p:spPr>
+        <p:txBody>
+          <a:bodyPr wrap="none">
+            <a:spAutoFit/>
+          </a:bodyPr>
+          <a:lstStyle/>
+          <a:p>
+            <a:pPr algn="ctr">
+              <a:defRPr sz="700"/>
+            </a:pPr>
+            <a:r>
+              <a:t>HW+SOP</a:t>
+            </a:r>
+          </a:p>
+        </p:txBody>
+      </p:sp>
+      <p:sp>
+        <p:nvSpPr>
+          <p:cNvPr id="36" name="Rectangle 35"/>
+          <p:cNvSpPr/>
+          <p:nvPr/>
+        </p:nvSpPr>
+        <p:spPr>
+          <a:xfrm>
+            <a:off x="7406640" y="2666772"/>
+            <a:ext cx="426720" cy="18130"/>
+          </a:xfrm>
+          <a:prstGeom prst="rect">
+            <a:avLst/>
+          </a:prstGeom>
+          <a:solidFill>
+            <a:srgbClr val="2E8B57"/>
+          </a:solidFill>
+          <a:ln>
+            <a:solidFill>
+              <a:srgbClr val="323232"/>
+            </a:solidFill>
+          </a:ln>
+        </p:spPr>
+        <p:style>
+          <a:lnRef idx="1">
+            <a:schemeClr val="accent1"/>
+          </a:lnRef>
+          <a:fillRef idx="3">
+            <a:schemeClr val="accent1"/>
+          </a:fillRef>
+          <a:effectRef idx="2">
+            <a:schemeClr val="accent1"/>
+          </a:effectRef>
+          <a:fontRef idx="minor">
+            <a:schemeClr val="lt1"/>
+          </a:fontRef>
+        </p:style>
+        <p:txBody>
+          <a:bodyPr rtlCol="0" anchor="ctr"/>
+          <a:lstStyle/>
+          <a:p>
+            <a:pPr algn="ctr"/>
+          </a:p>
+        </p:txBody>
+      </p:sp>
+      <p:sp>
+        <p:nvSpPr>
+          <p:cNvPr id="37" name="TextBox 36"/>
+          <p:cNvSpPr txBox="1"/>
+          <p:nvPr/>
+        </p:nvSpPr>
+        <p:spPr>
+          <a:xfrm>
+            <a:off x="7315200" y="3429000"/>
+            <a:ext cx="609600" cy="365760"/>
+          </a:xfrm>
+          <a:prstGeom prst="rect">
+            <a:avLst/>
+          </a:prstGeom>
+          <a:noFill/>
+        </p:spPr>
+        <p:txBody>
+          <a:bodyPr wrap="none">
+            <a:spAutoFit/>
+          </a:bodyPr>
+          <a:lstStyle/>
+          <a:p>
+            <a:pPr algn="ctr">
+              <a:defRPr sz="700"/>
+            </a:pPr>
+            <a:r>
+              <a:t>RPx</a:t>
+            </a:r>
+          </a:p>
+        </p:txBody>
+      </p:sp>
+      <p:sp>
+        <p:nvSpPr>
+          <p:cNvPr id="38" name="Rectangle 37"/>
+          <p:cNvSpPr/>
+          <p:nvPr/>
+        </p:nvSpPr>
+        <p:spPr>
+          <a:xfrm>
+            <a:off x="8046720" y="2684902"/>
+            <a:ext cx="426720" cy="698377"/>
+          </a:xfrm>
+          <a:prstGeom prst="rect">
+            <a:avLst/>
+          </a:prstGeom>
+          <a:solidFill>
+            <a:srgbClr val="DC143C"/>
+          </a:solidFill>
+          <a:ln>
+            <a:solidFill>
+              <a:srgbClr val="323232"/>
+            </a:solidFill>
+          </a:ln>
+        </p:spPr>
+        <p:style>
+          <a:lnRef idx="1">
+            <a:schemeClr val="accent1"/>
+          </a:lnRef>
+          <a:fillRef idx="3">
+            <a:schemeClr val="accent1"/>
+          </a:fillRef>
+          <a:effectRef idx="2">
+            <a:schemeClr val="accent1"/>
+          </a:effectRef>
+          <a:fontRef idx="minor">
+            <a:schemeClr val="lt1"/>
+          </a:fontRef>
+        </p:style>
+        <p:txBody>
+          <a:bodyPr rtlCol="0" anchor="ctr"/>
+          <a:lstStyle/>
+          <a:p>
+            <a:pPr algn="ctr"/>
+          </a:p>
+        </p:txBody>
+      </p:sp>
+      <p:sp>
+        <p:nvSpPr>
+          <p:cNvPr id="39" name="TextBox 38"/>
+          <p:cNvSpPr txBox="1"/>
+          <p:nvPr/>
+        </p:nvSpPr>
+        <p:spPr>
+          <a:xfrm>
+            <a:off x="8046720" y="2896931"/>
+            <a:ext cx="426720" cy="274320"/>
+          </a:xfrm>
+          <a:prstGeom prst="rect">
+            <a:avLst/>
+          </a:prstGeom>
+          <a:noFill/>
+        </p:spPr>
+        <p:txBody>
+          <a:bodyPr wrap="none">
+            <a:spAutoFit/>
+          </a:bodyPr>
+          <a:lstStyle/>
+          <a:p>
+            <a:pPr algn="ctr">
+              <a:defRPr sz="900" b="1">
+                <a:solidFill>
+                  <a:srgbClr val="FFFFFF"/>
+                </a:solidFill>
+              </a:defRPr>
+            </a:pPr>
+            <a:r>
+              <a:t>64.6</a:t>
+            </a:r>
+          </a:p>
+        </p:txBody>
+      </p:sp>
+      <p:sp>
+        <p:nvSpPr>
+          <p:cNvPr id="40" name="TextBox 39"/>
+          <p:cNvSpPr txBox="1"/>
+          <p:nvPr/>
+        </p:nvSpPr>
+        <p:spPr>
+          <a:xfrm>
+            <a:off x="7955280" y="3429000"/>
+            <a:ext cx="609600" cy="365760"/>
+          </a:xfrm>
+          <a:prstGeom prst="rect">
+            <a:avLst/>
+          </a:prstGeom>
+          <a:noFill/>
+        </p:spPr>
+        <p:txBody>
+          <a:bodyPr wrap="none">
+            <a:spAutoFit/>
+          </a:bodyPr>
+          <a:lstStyle/>
+          <a:p>
+            <a:pPr algn="ctr">
+              <a:defRPr sz="700"/>
+            </a:pPr>
+            <a:r>
+              <a:t>Customer</a:t>
+            </a:r>
+            <a:br/>
+            <a:r>
+              <a:t>Facing</a:t>
+            </a:r>
+          </a:p>
+        </p:txBody>
+      </p:sp>
+      <p:sp>
+        <p:nvSpPr>
+          <p:cNvPr id="41" name="Rectangle 40"/>
+          <p:cNvSpPr/>
+          <p:nvPr/>
+        </p:nvSpPr>
+        <p:spPr>
+          <a:xfrm>
+            <a:off x="5273040" y="1305098"/>
+            <a:ext cx="213360" cy="18288"/>
+          </a:xfrm>
+          <a:prstGeom prst="rect">
+            <a:avLst/>
+          </a:prstGeom>
+          <a:solidFill>
+            <a:srgbClr val="969696"/>
+          </a:solidFill>
+          <a:ln>
+            <a:noFill/>
+          </a:ln>
+        </p:spPr>
+        <p:style>
+          <a:lnRef idx="1">
+            <a:schemeClr val="accent1"/>
+          </a:lnRef>
+          <a:fillRef idx="3">
+            <a:schemeClr val="accent1"/>
+          </a:fillRef>
+          <a:effectRef idx="2">
+            <a:schemeClr val="accent1"/>
+          </a:effectRef>
+          <a:fontRef idx="minor">
+            <a:schemeClr val="lt1"/>
+          </a:fontRef>
+        </p:style>
+        <p:txBody>
+          <a:bodyPr rtlCol="0" anchor="ctr"/>
+          <a:lstStyle/>
+          <a:p>
+            <a:pPr algn="ctr"/>
+          </a:p>
+        </p:txBody>
+      </p:sp>
+      <p:sp>
+        <p:nvSpPr>
+          <p:cNvPr id="42" name="Rectangle 41"/>
+          <p:cNvSpPr/>
+          <p:nvPr/>
+        </p:nvSpPr>
+        <p:spPr>
+          <a:xfrm>
+            <a:off x="5913120" y="2421589"/>
+            <a:ext cx="213359" cy="18288"/>
+          </a:xfrm>
+          <a:prstGeom prst="rect">
+            <a:avLst/>
+          </a:prstGeom>
+          <a:solidFill>
+            <a:srgbClr val="969696"/>
+          </a:solidFill>
+          <a:ln>
+            <a:noFill/>
+          </a:ln>
+        </p:spPr>
+        <p:style>
+          <a:lnRef idx="1">
+            <a:schemeClr val="accent1"/>
+          </a:lnRef>
+          <a:fillRef idx="3">
+            <a:schemeClr val="accent1"/>
+          </a:fillRef>
+          <a:effectRef idx="2">
+            <a:schemeClr val="accent1"/>
+          </a:effectRef>
+          <a:fontRef idx="minor">
+            <a:schemeClr val="lt1"/>
+          </a:fontRef>
+        </p:style>
+        <p:txBody>
+          <a:bodyPr rtlCol="0" anchor="ctr"/>
+          <a:lstStyle/>
+          <a:p>
+            <a:pPr algn="ctr"/>
+          </a:p>
+        </p:txBody>
+      </p:sp>
+      <p:sp>
+        <p:nvSpPr>
+          <p:cNvPr id="43" name="Rectangle 42"/>
+          <p:cNvSpPr/>
+          <p:nvPr/>
+        </p:nvSpPr>
+        <p:spPr>
+          <a:xfrm>
+            <a:off x="6553199" y="2659849"/>
+            <a:ext cx="213360" cy="18288"/>
+          </a:xfrm>
+          <a:prstGeom prst="rect">
+            <a:avLst/>
+          </a:prstGeom>
+          <a:solidFill>
+            <a:srgbClr val="969696"/>
+          </a:solidFill>
+          <a:ln>
+            <a:noFill/>
+          </a:ln>
+        </p:spPr>
+        <p:style>
+          <a:lnRef idx="1">
+            <a:schemeClr val="accent1"/>
+          </a:lnRef>
+          <a:fillRef idx="3">
+            <a:schemeClr val="accent1"/>
+          </a:fillRef>
+          <a:effectRef idx="2">
+            <a:schemeClr val="accent1"/>
+          </a:effectRef>
+          <a:fontRef idx="minor">
+            <a:schemeClr val="lt1"/>
+          </a:fontRef>
+        </p:style>
+        <p:txBody>
+          <a:bodyPr rtlCol="0" anchor="ctr"/>
+          <a:lstStyle/>
+          <a:p>
+            <a:pPr algn="ctr"/>
+          </a:p>
+        </p:txBody>
+      </p:sp>
+      <p:sp>
+        <p:nvSpPr>
+          <p:cNvPr id="44" name="Rectangle 43"/>
+          <p:cNvSpPr/>
+          <p:nvPr/>
+        </p:nvSpPr>
+        <p:spPr>
+          <a:xfrm>
+            <a:off x="7193280" y="2666772"/>
+            <a:ext cx="213360" cy="18288"/>
+          </a:xfrm>
+          <a:prstGeom prst="rect">
+            <a:avLst/>
+          </a:prstGeom>
+          <a:solidFill>
+            <a:srgbClr val="969696"/>
+          </a:solidFill>
+          <a:ln>
+            <a:noFill/>
+          </a:ln>
+        </p:spPr>
+        <p:style>
+          <a:lnRef idx="1">
+            <a:schemeClr val="accent1"/>
+          </a:lnRef>
+          <a:fillRef idx="3">
+            <a:schemeClr val="accent1"/>
+          </a:fillRef>
+          <a:effectRef idx="2">
+            <a:schemeClr val="accent1"/>
+          </a:effectRef>
+          <a:fontRef idx="minor">
+            <a:schemeClr val="lt1"/>
+          </a:fontRef>
+        </p:style>
+        <p:txBody>
+          <a:bodyPr rtlCol="0" anchor="ctr"/>
+          <a:lstStyle/>
+          <a:p>
+            <a:pPr algn="ctr"/>
+          </a:p>
+        </p:txBody>
+      </p:sp>
+      <p:sp>
+        <p:nvSpPr>
+          <p:cNvPr id="45" name="Rectangle 44"/>
+          <p:cNvSpPr/>
+          <p:nvPr/>
+        </p:nvSpPr>
+        <p:spPr>
+          <a:xfrm>
+            <a:off x="7833360" y="2684902"/>
+            <a:ext cx="213360" cy="18288"/>
+          </a:xfrm>
+          <a:prstGeom prst="rect">
+            <a:avLst/>
+          </a:prstGeom>
+          <a:solidFill>
+            <a:srgbClr val="969696"/>
+          </a:solidFill>
+          <a:ln>
+            <a:noFill/>
+          </a:ln>
+        </p:spPr>
+        <p:style>
+          <a:lnRef idx="1">
+            <a:schemeClr val="accent1"/>
+          </a:lnRef>
+          <a:fillRef idx="3">
+            <a:schemeClr val="accent1"/>
+          </a:fillRef>
+          <a:effectRef idx="2">
+            <a:schemeClr val="accent1"/>
+          </a:effectRef>
+          <a:fontRef idx="minor">
+            <a:schemeClr val="lt1"/>
+          </a:fontRef>
+        </p:style>
+        <p:txBody>
+          <a:bodyPr rtlCol="0" anchor="ctr"/>
+          <a:lstStyle/>
+          <a:p>
+            <a:pPr algn="ctr"/>
+          </a:p>
+        </p:txBody>
+      </p:sp>
+      <p:sp>
+        <p:nvSpPr>
+          <p:cNvPr id="46" name="TextBox 45"/>
+          <p:cNvSpPr txBox="1"/>
+          <p:nvPr/>
+        </p:nvSpPr>
+        <p:spPr>
+          <a:xfrm>
+            <a:off x="4846320" y="731519"/>
+            <a:ext cx="3840480" cy="274320"/>
+          </a:xfrm>
+          <a:prstGeom prst="rect">
+            <a:avLst/>
+          </a:prstGeom>
+          <a:noFill/>
+        </p:spPr>
+        <p:txBody>
+          <a:bodyPr wrap="none">
+            <a:spAutoFit/>
+          </a:bodyPr>
+          <a:lstStyle/>
+          <a:p>
+            <a:pPr algn="ctr">
+              <a:defRPr sz="1200" b="1"/>
+            </a:pPr>
+            <a:r>
+              <a:t>QMON</a:t>
+            </a:r>
+          </a:p>
+        </p:txBody>
+      </p:sp>
+      <p:sp>
+        <p:nvSpPr>
+          <p:cNvPr id="47" name="Rounded Rectangle 46"/>
+          <p:cNvSpPr/>
+          <p:nvPr/>
+        </p:nvSpPr>
+        <p:spPr>
+          <a:xfrm>
+            <a:off x="457200" y="3657600"/>
+            <a:ext cx="8229600" cy="1097280"/>
+          </a:xfrm>
+          <a:prstGeom prst="roundRect">
+            <a:avLst/>
+          </a:prstGeom>
+          <a:solidFill>
+            <a:srgbClr val="F0F8FF"/>
+          </a:solidFill>
+        </p:spPr>
+        <p:style>
+          <a:lnRef idx="1">
+            <a:schemeClr val="accent1"/>
+          </a:lnRef>
+          <a:fillRef idx="3">
+            <a:schemeClr val="accent1"/>
+          </a:fillRef>
+          <a:effectRef idx="2">
+            <a:schemeClr val="accent1"/>
+          </a:effectRef>
+          <a:fontRef idx="minor">
+            <a:schemeClr val="lt1"/>
+          </a:fontRef>
+        </p:style>
+        <p:txBody>
+          <a:bodyPr rtlCol="0" anchor="ctr" wrap="square"/>
+          <a:lstStyle/>
+          <a:p>
+            <a:pPr algn="ctr">
+              <a:defRPr sz="1400" b="1">
+                <a:solidFill>
+                  <a:srgbClr val="003366"/>
+                </a:solidFill>
+              </a:defRPr>
+            </a:pPr>
+            <a:r>
+              <a:t>Combined SLT Summary</a:t>
+            </a:r>
+          </a:p>
+          <a:p>
+            <a:pPr>
+              <a:defRPr sz="1200"/>
+            </a:pPr>
+            <a:r>
+              <a:t>Total DPM: 458.19 → Recovered: 281.00 → Customer-Facing: 177.19</a:t>
+            </a:r>
+          </a:p>
+          <a:p>
+            <a:pPr>
+              <a:defRPr sz="1100">
+                <a:solidFill>
+                  <a:srgbClr val="2E8B57"/>
+                </a:solidFill>
+              </a:defRPr>
+            </a:pPr>
+            <a:r>
+              <a:t>Recovery Rate: 61.3% | Customer Impact Reduction: 61.3%</a:t>
+            </a:r>
+          </a:p>
+        </p:txBody>
+      </p:sp>
+      <p:sp>
+        <p:nvSpPr>
+          <p:cNvPr id="48" name="TextBox 47"/>
+          <p:cNvSpPr txBox="1"/>
+          <p:nvPr/>
+        </p:nvSpPr>
+        <p:spPr>
+          <a:xfrm>
+            <a:off x="457200" y="4937760"/>
+            <a:ext cx="8229600" cy="731520"/>
+          </a:xfrm>
+          <a:prstGeom prst="rect">
+            <a:avLst/>
+          </a:prstGeom>
+          <a:noFill/>
+        </p:spPr>
+        <p:txBody>
+          <a:bodyPr wrap="square">
+            <a:spAutoFit/>
+          </a:bodyPr>
+          <a:lstStyle/>
+          <a:p>
+            <a:pPr>
+              <a:defRPr sz="1000"/>
+            </a:pPr>
+            <a:r>
+              <a:t>Legend: ■ Blue = Total DPM | ■ Green = Recovery (BIOS/HW+SOP) | ■ Red = Customer-Facing DPM</a:t>
+            </a:r>
+          </a:p>
+          <a:p>
+            <a:pPr>
+              <a:defRPr sz="900">
+                <a:solidFill>
+                  <a:srgbClr val="646464"/>
+                </a:solidFill>
+              </a:defRPr>
+            </a:pPr>
+            <a:r>
+              <a:t>Note: RPx verified rate is ~0%, so RPx failures remain in customer-facing DPM. No Recovery (SB/DB) are DRAM defects.</a:t>
             </a:r>
           </a:p>
         </p:txBody>

</xml_diff>